<commit_message>
feat(curriculum): integrar seguridad en lanzamientos virales
</commit_message>
<xml_diff>
--- a/classes/parte-12-osint-e-ingenieria-social/252-osint-en-redes-sociales/clase-252-presentacion.pptx
+++ b/classes/parte-12-osint-e-ingenieria-social/252-osint-en-redes-sociales/clase-252-presentacion.pptx
@@ -3480,7 +3480,7 @@
                   <a:srgbClr val="22282E"/>
                 </a:solidFill>
               </a:rPr>
-              <a:t>•  Simula la perspectiva de un atacante: ¿qué pretexto construirías con estos datos?</a:t>
+              <a:t>•  Modela la perspectiva de amenaza sin redactar un pretexto operativo: ¿qué decisión sensible podría intentar provocar un tercero con esos datos y qué control la bloquearía?</a:t>
             </a:r>
           </a:p>
         </p:txBody>
@@ -3647,6 +3647,21 @@
               <a:t>•  Investiga qué prohíben los ToS de una red sobre scraping y automatización.</a:t>
             </a:r>
           </a:p>
+          <a:p>
+            <a:pPr>
+              <a:spcAft>
+                <a:spcPts val="600"/>
+              </a:spcAft>
+            </a:pPr>
+            <a:r>
+              <a:rPr sz="1500">
+                <a:solidFill>
+                  <a:srgbClr val="22282E"/>
+                </a:solidFill>
+              </a:rPr>
+              <a:t>•  Explica por qué una publicación desde la cuenta oficial puede ser menos confiable durante una sesión anómala que un aviso coherente publicado por dos canales independientes.</a:t>
+            </a:r>
+          </a:p>
         </p:txBody>
       </p:sp>
     </p:spTree>
@@ -3930,6 +3945,36 @@
               <a:t>•  Geotag mal interpretado — Ubicación de la foto ≠ ubicación de residencia. Corrobora con más datos.</a:t>
             </a:r>
           </a:p>
+          <a:p>
+            <a:pPr>
+              <a:spcAft>
+                <a:spcPts val="600"/>
+              </a:spcAft>
+            </a:pPr>
+            <a:r>
+              <a:rPr sz="1500">
+                <a:solidFill>
+                  <a:srgbClr val="22282E"/>
+                </a:solidFill>
+              </a:rPr>
+              <a:t>•  Handle correcto = operador legítimo — Una cuenta auténtica puede estar tomada; busca evidencia de sesión y recuperación.</a:t>
+            </a:r>
+          </a:p>
+          <a:p>
+            <a:pPr>
+              <a:spcAft>
+                <a:spcPts val="600"/>
+              </a:spcAft>
+            </a:pPr>
+            <a:r>
+              <a:rPr sz="1500">
+                <a:solidFill>
+                  <a:srgbClr val="22282E"/>
+                </a:solidFill>
+              </a:rPr>
+              <a:t>•  Seguidores = autoridad — Las métricas se compran, heredan o manipulan; exige procedencia y corroboración.</a:t>
+            </a:r>
+          </a:p>
         </p:txBody>
       </p:sp>
     </p:spTree>
@@ -4241,6 +4286,21 @@
                 </a:solidFill>
               </a:rPr>
               <a:t>•  OSINT Framework — Social Networks. &lt;https://osintframework.com/&gt;</a:t>
+            </a:r>
+          </a:p>
+          <a:p>
+            <a:pPr>
+              <a:spcAft>
+                <a:spcPts val="600"/>
+              </a:spcAft>
+            </a:pPr>
+            <a:r>
+              <a:rPr sz="1500">
+                <a:solidFill>
+                  <a:srgbClr val="22282E"/>
+                </a:solidFill>
+              </a:rPr>
+              <a:t>•  SEC — alerta sobre estafas con criptoactivos: documenta suplantación, cuentas sociales comprometidas, deepfakes y promoción de memecoins; se usa para reconocer mecanismos, no para juzgar una…</a:t>
             </a:r>
           </a:p>
         </p:txBody>
@@ -4750,6 +4810,21 @@
               <a:t>•  Documentar hallazgos evitando sesgos y respetando la privacidad.</a:t>
             </a:r>
           </a:p>
+          <a:p>
+            <a:pPr>
+              <a:spcAft>
+                <a:spcPts val="600"/>
+              </a:spcAft>
+            </a:pPr>
+            <a:r>
+              <a:rPr sz="1500">
+                <a:solidFill>
+                  <a:srgbClr val="22282E"/>
+                </a:solidFill>
+              </a:rPr>
+              <a:t>•  Diferenciar una cuenta imitadora, una cuenta auténtica comprometida y un influencer no corroborado.</a:t>
+            </a:r>
+          </a:p>
         </p:txBody>
       </p:sp>
     </p:spTree>
@@ -5078,6 +5153,36 @@
               <a:t>•  Un video se comparte como prueba de un incidente actual. La búsqueda inversa encuentra copias de dos años antes y los edificios no coinciden con el lugar afirmado. El analista conserva la publicación…</a:t>
             </a:r>
           </a:p>
+          <a:p>
+            <a:pPr>
+              <a:spcAft>
+                <a:spcPts val="600"/>
+              </a:spcAft>
+            </a:pPr>
+            <a:r>
+              <a:rPr sz="1500">
+                <a:solidFill>
+                  <a:srgbClr val="22282E"/>
+                </a:solidFill>
+              </a:rPr>
+              <a:t>•  Un video atribuido a una figura popular anuncia un memecoin y pide buscarlo antes de que termine un</a:t>
+            </a:r>
+          </a:p>
+          <a:p>
+            <a:pPr>
+              <a:spcAft>
+                <a:spcPts val="600"/>
+              </a:spcAft>
+            </a:pPr>
+            <a:r>
+              <a:rPr sz="1500">
+                <a:solidFill>
+                  <a:srgbClr val="22282E"/>
+                </a:solidFill>
+              </a:rPr>
+              <a:t>•  airdrop. La búsqueda devuelve varias cuentas con el mismo avatar y símbolo. Una cambia una letra del</a:t>
+            </a:r>
+          </a:p>
         </p:txBody>
       </p:sp>
     </p:spTree>
@@ -5240,6 +5345,21 @@
                 </a:solidFill>
               </a:rPr>
               <a:t>•  Identificador de publicación — Clave estable de plataforma preferible a una captura aislada.</a:t>
+            </a:r>
+          </a:p>
+          <a:p>
+            <a:pPr>
+              <a:spcAft>
+                <a:spcPts val="600"/>
+              </a:spcAft>
+            </a:pPr>
+            <a:r>
+              <a:rPr sz="1500">
+                <a:solidFill>
+                  <a:srgbClr val="22282E"/>
+                </a:solidFill>
+              </a:rPr>
+              <a:t>•  Cuenta imitadora — Perfil distinto que copia señales visuales o un identificador parecido.</a:t>
             </a:r>
           </a:p>
         </p:txBody>

</xml_diff>